<commit_message>
更新：LoRA微调(IoU 0.839/BER 0.050,超U-Net) + 重写结题报告/答辩稿/PPT + demo支持LoRA
</commit_message>
<xml_diff>
--- a/结题答辩PPT_最终版.pptx
+++ b/结题答辩PPT_最终版.pptx
@@ -3252,7 +3252,7 @@
         <p:spPr>
           <a:xfrm>
             <a:off x="457200" y="1371600"/>
-            <a:ext cx="11247120" cy="1709648"/>
+            <a:ext cx="11247120" cy="1995862"/>
           </a:xfrm>
           <a:prstGeom prst="rect">
             <a:avLst/>
@@ -3347,7 +3347,7 @@
                 <a:latin typeface="Microsoft YaHei"/>
                 <a:ea typeface="Microsoft YaHei"/>
               </a:rPr>
-              <a:t>参数高效微调释放基础模型潜力：冻结编码器、只训 4.34% 参数，IoU 提升 0.48</a:t>
+              <a:t>LoRA 参数高效微调：只训 4.8% 参数，零样本 IoU 提升 0.605，超过全监督 U-Net</a:t>
             </a:r>
           </a:p>
           <a:p>
@@ -3381,7 +3381,7 @@
                 <a:latin typeface="Microsoft YaHei"/>
                 <a:ea typeface="Microsoft YaHei"/>
               </a:rPr>
-              <a:t>增强物理预处理：零训练将传统 Otsu 的 IoU 提升约 0.09</a:t>
+              <a:t>「零样本 → 冻结微调 → LoRA 微调」的完整技术演进路径</a:t>
             </a:r>
           </a:p>
           <a:p>
@@ -3398,7 +3398,7 @@
                 <a:latin typeface="Microsoft YaHei"/>
                 <a:ea typeface="Microsoft YaHei"/>
               </a:rPr>
-              <a:t>标准数据集 + 六项指标 + 消融 + 零样本/微调对比的完整可复现评估体系</a:t>
+              <a:t>标准数据集 + 六项指标 + 消融 + 零样本/冻结/LoRA/U-Net 对比的完整可复现评估体系</a:t>
             </a:r>
           </a:p>
         </p:txBody>
@@ -4081,7 +4081,7 @@
                 <a:latin typeface="Microsoft YaHei"/>
                 <a:ea typeface="Microsoft YaHei"/>
               </a:rPr>
-              <a:t>方法 ②：参数高效微调 SAM（核心）</a:t>
+              <a:t>方法 ②：LoRA 参数高效微调 SAM（核心）</a:t>
             </a:r>
           </a:p>
         </p:txBody>
@@ -4121,7 +4121,7 @@
                 <a:latin typeface="Microsoft YaHei"/>
                 <a:ea typeface="Microsoft YaHei"/>
               </a:rPr>
-              <a:t>冻结图像编码器（ViT-B，占绝大部分参数）</a:t>
+              <a:t>在 SAM 图像编码器注意力层挂 LoRA（低秩适配，rank=8）</a:t>
             </a:r>
           </a:p>
           <a:p>
@@ -4138,7 +4138,7 @@
                 <a:latin typeface="Microsoft YaHei"/>
                 <a:ea typeface="Microsoft YaHei"/>
               </a:rPr>
-              <a:t>仅训练掩膜解码器 + 提示编码器：4.06M 参数，仅占总参数 93.7M 的 4.34%</a:t>
+              <a:t>冻结原权重，只训练 LoRA（0.44M）+ 解码器 + 提示编码器，共 4.51M（约 4.8%）</a:t>
             </a:r>
           </a:p>
           <a:p>
@@ -4155,7 +4155,7 @@
                 <a:latin typeface="Microsoft YaHei"/>
                 <a:ea typeface="Microsoft YaHei"/>
               </a:rPr>
-              <a:t>Focal Loss + Dice 损失，点/框双提示训练，水平翻转增强，余弦学习率</a:t>
+              <a:t>Focal Loss + Dice 损失，点/框双提示，水平翻转增强，混合精度加速</a:t>
             </a:r>
           </a:p>
           <a:p>
@@ -4172,24 +4172,7 @@
                 <a:latin typeface="Microsoft YaHei"/>
                 <a:ea typeface="Microsoft YaHei"/>
               </a:rPr>
-              <a:t>AISD 训练集 412 张、150 个 epoch，RTX 4060（8GB），约 6 小时</a:t>
-            </a:r>
-          </a:p>
-          <a:p>
-            <a:pPr>
-              <a:spcAft>
-                <a:spcPts val="800"/>
-              </a:spcAft>
-            </a:pPr>
-            <a:r>
-              <a:rPr sz="2000" b="0">
-                <a:solidFill>
-                  <a:srgbClr val="1F3B63"/>
-                </a:solidFill>
-                <a:latin typeface="Microsoft YaHei"/>
-                <a:ea typeface="Microsoft YaHei"/>
-              </a:rPr>
-              <a:t>结果：把零样本 SAM 的 IoU 从 0.23 提升到 0.72</a:t>
+              <a:t>结果：零样本 SAM 的 IoU 从 0.234 提升到 0.839，超过全监督 U-Net（0.805）</a:t>
             </a:r>
           </a:p>
         </p:txBody>
@@ -4559,7 +4542,7 @@
                 <a:gridCol w="2491740"/>
                 <a:gridCol w="2491740"/>
               </a:tblGrid>
-              <a:tr h="548640">
+              <a:tr h="480060">
                 <a:tc>
                   <a:txBody>
                     <a:bodyPr/>
@@ -4641,7 +4624,7 @@
                   <a:tcPr/>
                 </a:tc>
               </a:tr>
-              <a:tr h="548640">
+              <a:tr h="480060">
                 <a:tc>
                   <a:txBody>
                     <a:bodyPr/>
@@ -4723,7 +4706,7 @@
                   <a:tcPr/>
                 </a:tc>
               </a:tr>
-              <a:tr h="548640">
+              <a:tr h="480060">
                 <a:tc>
                   <a:txBody>
                     <a:bodyPr/>
@@ -4805,7 +4788,7 @@
                   <a:tcPr/>
                 </a:tc>
               </a:tr>
-              <a:tr h="548640">
+              <a:tr h="480060">
                 <a:tc>
                   <a:txBody>
                     <a:bodyPr/>
@@ -4887,89 +4870,7 @@
                   <a:tcPr/>
                 </a:tc>
               </a:tr>
-              <a:tr h="548640">
-                <a:tc>
-                  <a:txBody>
-                    <a:bodyPr/>
-                    <a:lstStyle/>
-                    <a:p>
-                      <a:pPr algn="ctr"/>
-                      <a:r>
-                        <a:rPr sz="1500" b="0">
-                          <a:solidFill>
-                            <a:srgbClr val="1F3B63"/>
-                          </a:solidFill>
-                          <a:latin typeface="Microsoft YaHei"/>
-                          <a:ea typeface="Microsoft YaHei"/>
-                        </a:rPr>
-                        <a:t>零样本SAM+自动提示</a:t>
-                      </a:r>
-                    </a:p>
-                  </a:txBody>
-                  <a:tcPr/>
-                </a:tc>
-                <a:tc>
-                  <a:txBody>
-                    <a:bodyPr/>
-                    <a:lstStyle/>
-                    <a:p>
-                      <a:pPr algn="ctr"/>
-                      <a:r>
-                        <a:rPr sz="1500" b="0">
-                          <a:solidFill>
-                            <a:srgbClr val="1F3B63"/>
-                          </a:solidFill>
-                          <a:latin typeface="Microsoft YaHei"/>
-                          <a:ea typeface="Microsoft YaHei"/>
-                        </a:rPr>
-                        <a:t>0.234</a:t>
-                      </a:r>
-                    </a:p>
-                  </a:txBody>
-                  <a:tcPr/>
-                </a:tc>
-                <a:tc>
-                  <a:txBody>
-                    <a:bodyPr/>
-                    <a:lstStyle/>
-                    <a:p>
-                      <a:pPr algn="ctr"/>
-                      <a:r>
-                        <a:rPr sz="1500" b="0">
-                          <a:solidFill>
-                            <a:srgbClr val="1F3B63"/>
-                          </a:solidFill>
-                          <a:latin typeface="Microsoft YaHei"/>
-                          <a:ea typeface="Microsoft YaHei"/>
-                        </a:rPr>
-                        <a:t>0.430</a:t>
-                      </a:r>
-                    </a:p>
-                  </a:txBody>
-                  <a:tcPr/>
-                </a:tc>
-                <a:tc>
-                  <a:txBody>
-                    <a:bodyPr/>
-                    <a:lstStyle/>
-                    <a:p>
-                      <a:pPr algn="ctr"/>
-                      <a:r>
-                        <a:rPr sz="1500" b="0">
-                          <a:solidFill>
-                            <a:srgbClr val="1F3B63"/>
-                          </a:solidFill>
-                          <a:latin typeface="Microsoft YaHei"/>
-                          <a:ea typeface="Microsoft YaHei"/>
-                        </a:rPr>
-                        <a:t>0.370</a:t>
-                      </a:r>
-                    </a:p>
-                  </a:txBody>
-                  <a:tcPr/>
-                </a:tc>
-              </a:tr>
-              <a:tr h="548640">
+              <a:tr h="480060">
                 <a:tc>
                   <a:txBody>
                     <a:bodyPr/>
@@ -5051,7 +4952,171 @@
                   <a:tcPr/>
                 </a:tc>
               </a:tr>
-              <a:tr h="548640">
+              <a:tr h="480060">
+                <a:tc>
+                  <a:txBody>
+                    <a:bodyPr/>
+                    <a:lstStyle/>
+                    <a:p>
+                      <a:pPr algn="ctr"/>
+                      <a:r>
+                        <a:rPr sz="1500" b="0">
+                          <a:solidFill>
+                            <a:srgbClr val="1F3B63"/>
+                          </a:solidFill>
+                          <a:latin typeface="Microsoft YaHei"/>
+                          <a:ea typeface="Microsoft YaHei"/>
+                        </a:rPr>
+                        <a:t>冻结编码器微调 SAM</a:t>
+                      </a:r>
+                    </a:p>
+                  </a:txBody>
+                  <a:tcPr/>
+                </a:tc>
+                <a:tc>
+                  <a:txBody>
+                    <a:bodyPr/>
+                    <a:lstStyle/>
+                    <a:p>
+                      <a:pPr algn="ctr"/>
+                      <a:r>
+                        <a:rPr sz="1500" b="0">
+                          <a:solidFill>
+                            <a:srgbClr val="1F3B63"/>
+                          </a:solidFill>
+                          <a:latin typeface="Microsoft YaHei"/>
+                          <a:ea typeface="Microsoft YaHei"/>
+                        </a:rPr>
+                        <a:t>0.717</a:t>
+                      </a:r>
+                    </a:p>
+                  </a:txBody>
+                  <a:tcPr/>
+                </a:tc>
+                <a:tc>
+                  <a:txBody>
+                    <a:bodyPr/>
+                    <a:lstStyle/>
+                    <a:p>
+                      <a:pPr algn="ctr"/>
+                      <a:r>
+                        <a:rPr sz="1500" b="0">
+                          <a:solidFill>
+                            <a:srgbClr val="1F3B63"/>
+                          </a:solidFill>
+                          <a:latin typeface="Microsoft YaHei"/>
+                          <a:ea typeface="Microsoft YaHei"/>
+                        </a:rPr>
+                        <a:t>0.109</a:t>
+                      </a:r>
+                    </a:p>
+                  </a:txBody>
+                  <a:tcPr/>
+                </a:tc>
+                <a:tc>
+                  <a:txBody>
+                    <a:bodyPr/>
+                    <a:lstStyle/>
+                    <a:p>
+                      <a:pPr algn="ctr"/>
+                      <a:r>
+                        <a:rPr sz="1500" b="0">
+                          <a:solidFill>
+                            <a:srgbClr val="1F3B63"/>
+                          </a:solidFill>
+                          <a:latin typeface="Microsoft YaHei"/>
+                          <a:ea typeface="Microsoft YaHei"/>
+                        </a:rPr>
+                        <a:t>0.833</a:t>
+                      </a:r>
+                    </a:p>
+                  </a:txBody>
+                  <a:tcPr/>
+                </a:tc>
+              </a:tr>
+              <a:tr h="480060">
+                <a:tc>
+                  <a:txBody>
+                    <a:bodyPr/>
+                    <a:lstStyle/>
+                    <a:p>
+                      <a:pPr algn="ctr"/>
+                      <a:r>
+                        <a:rPr sz="1500" b="0">
+                          <a:solidFill>
+                            <a:srgbClr val="1F3B63"/>
+                          </a:solidFill>
+                          <a:latin typeface="Microsoft YaHei"/>
+                          <a:ea typeface="Microsoft YaHei"/>
+                        </a:rPr>
+                        <a:t>全监督 U-Net</a:t>
+                      </a:r>
+                    </a:p>
+                  </a:txBody>
+                  <a:tcPr/>
+                </a:tc>
+                <a:tc>
+                  <a:txBody>
+                    <a:bodyPr/>
+                    <a:lstStyle/>
+                    <a:p>
+                      <a:pPr algn="ctr"/>
+                      <a:r>
+                        <a:rPr sz="1500" b="0">
+                          <a:solidFill>
+                            <a:srgbClr val="1F3B63"/>
+                          </a:solidFill>
+                          <a:latin typeface="Microsoft YaHei"/>
+                          <a:ea typeface="Microsoft YaHei"/>
+                        </a:rPr>
+                        <a:t>0.805</a:t>
+                      </a:r>
+                    </a:p>
+                  </a:txBody>
+                  <a:tcPr/>
+                </a:tc>
+                <a:tc>
+                  <a:txBody>
+                    <a:bodyPr/>
+                    <a:lstStyle/>
+                    <a:p>
+                      <a:pPr algn="ctr"/>
+                      <a:r>
+                        <a:rPr sz="1500" b="0">
+                          <a:solidFill>
+                            <a:srgbClr val="1F3B63"/>
+                          </a:solidFill>
+                          <a:latin typeface="Microsoft YaHei"/>
+                          <a:ea typeface="Microsoft YaHei"/>
+                        </a:rPr>
+                        <a:t>—</a:t>
+                      </a:r>
+                    </a:p>
+                  </a:txBody>
+                  <a:tcPr/>
+                </a:tc>
+                <a:tc>
+                  <a:txBody>
+                    <a:bodyPr/>
+                    <a:lstStyle/>
+                    <a:p>
+                      <a:pPr algn="ctr"/>
+                      <a:r>
+                        <a:rPr sz="1500" b="0">
+                          <a:solidFill>
+                            <a:srgbClr val="1F3B63"/>
+                          </a:solidFill>
+                          <a:latin typeface="Microsoft YaHei"/>
+                          <a:ea typeface="Microsoft YaHei"/>
+                        </a:rPr>
+                        <a:t>—</a:t>
+                      </a:r>
+                    </a:p>
+                  </a:txBody>
+                  <a:tcPr/>
+                </a:tc>
+              </a:tr>
+              <a:tr h="480060">
                 <a:tc>
                   <a:txBody>
                     <a:bodyPr/>
@@ -5066,7 +5131,7 @@
                           <a:latin typeface="Microsoft YaHei"/>
                           <a:ea typeface="Microsoft YaHei"/>
                         </a:rPr>
-                        <a:t>微调SAM+框提示（本项目）</a:t>
+                        <a:t>LoRA 微调 SAM（本项目）</a:t>
                       </a:r>
                     </a:p>
                   </a:txBody>
@@ -5090,7 +5155,7 @@
                           <a:latin typeface="Microsoft YaHei"/>
                           <a:ea typeface="Microsoft YaHei"/>
                         </a:rPr>
-                        <a:t>0.717</a:t>
+                        <a:t>0.839</a:t>
                       </a:r>
                     </a:p>
                   </a:txBody>
@@ -5114,7 +5179,7 @@
                           <a:latin typeface="Microsoft YaHei"/>
                           <a:ea typeface="Microsoft YaHei"/>
                         </a:rPr>
-                        <a:t>0.109</a:t>
+                        <a:t>0.050</a:t>
                       </a:r>
                     </a:p>
                   </a:txBody>
@@ -5138,7 +5203,7 @@
                           <a:latin typeface="Microsoft YaHei"/>
                           <a:ea typeface="Microsoft YaHei"/>
                         </a:rPr>
-                        <a:t>0.833</a:t>
+                        <a:t>0.912</a:t>
                       </a:r>
                     </a:p>
                   </a:txBody>

</xml_diff>